<commit_message>
Fix capstone company size labels
</commit_message>
<xml_diff>
--- a/tasks/Data Analytics Capstone Project/outputs/presentation/osmi_mental_health_capstone_presentation.pptx
+++ b/tasks/Data Analytics Capstone Project/outputs/presentation/osmi_mental_health_capstone_presentation.pptx
@@ -2804,7 +2804,7 @@
                 </a:solidFill>
                 <a:latin typeface="Aptos"/>
               </a:rPr>
-              <a:t>The raw file has 1,259 responses and 27 columns; the cleaned analysis file has 56 columns after variable creation.</a:t>
+              <a:t>The raw file has 1,259 responses and 27 columns; the cleaned analysis file has 57 columns after variable creation.</a:t>
             </a:r>
           </a:p>
         </p:txBody>
@@ -3221,7 +3221,7 @@
                 </a:solidFill>
                 <a:latin typeface="Aptos"/>
               </a:rPr>
-              <a:t>56</a:t>
+              <a:t>57</a:t>
             </a:r>
           </a:p>
         </p:txBody>

</xml_diff>